<commit_message>
ajustes nas referencias das páginas e ajustes na apresentação
</commit_message>
<xml_diff>
--- a/coisas/Apresentação TG.pptx
+++ b/coisas/Apresentação TG.pptx
@@ -377,7 +377,7 @@
             <a:pPr indent="0" algn="r">
               <a:buNone/>
             </a:pPr>
-            <a:fld id="{608A1816-261A-4C92-80AF-4AD3D7BAE5BC}" type="slidenum">
+            <a:fld id="{81A101E5-3B2F-4249-AA5B-C7C1A3069115}" type="slidenum">
               <a:rPr b="0" lang="pt-BR" sz="1400" strike="noStrike" u="none">
                 <a:solidFill>
                   <a:srgbClr val="000000"/>
@@ -424,7 +424,7 @@
       </p:grpSpPr>
       <p:sp>
         <p:nvSpPr>
-          <p:cNvPr id="148" name="PlaceHolder 1"/>
+          <p:cNvPr id="149" name="PlaceHolder 1"/>
           <p:cNvSpPr>
             <a:spLocks noGrp="1"/>
           </p:cNvSpPr>
@@ -435,7 +435,7 @@
         <p:spPr>
           <a:xfrm>
             <a:off x="685800" y="4400640"/>
-            <a:ext cx="5484600" cy="3598920"/>
+            <a:ext cx="5484240" cy="3598560"/>
           </a:xfrm>
           <a:prstGeom prst="rect">
             <a:avLst/>
@@ -484,7 +484,7 @@
       </p:sp>
       <p:sp>
         <p:nvSpPr>
-          <p:cNvPr id="149" name="PlaceHolder 2"/>
+          <p:cNvPr id="150" name="PlaceHolder 2"/>
           <p:cNvSpPr>
             <a:spLocks noGrp="1"/>
           </p:cNvSpPr>
@@ -495,7 +495,7 @@
         <p:spPr>
           <a:xfrm>
             <a:off x="685800" y="1143000"/>
-            <a:ext cx="5484600" cy="3084480"/>
+            <a:ext cx="5484240" cy="3084120"/>
           </a:xfrm>
           <a:prstGeom prst="rect">
             <a:avLst/>
@@ -529,7 +529,7 @@
       </p:grpSpPr>
       <p:sp>
         <p:nvSpPr>
-          <p:cNvPr id="150" name="PlaceHolder 1"/>
+          <p:cNvPr id="151" name="PlaceHolder 1"/>
           <p:cNvSpPr>
             <a:spLocks noGrp="1"/>
           </p:cNvSpPr>
@@ -540,7 +540,7 @@
         <p:spPr>
           <a:xfrm>
             <a:off x="685800" y="4400640"/>
-            <a:ext cx="5484600" cy="3598920"/>
+            <a:ext cx="5484240" cy="3598560"/>
           </a:xfrm>
           <a:prstGeom prst="rect">
             <a:avLst/>
@@ -589,7 +589,7 @@
       </p:sp>
       <p:sp>
         <p:nvSpPr>
-          <p:cNvPr id="151" name="PlaceHolder 2"/>
+          <p:cNvPr id="152" name="PlaceHolder 2"/>
           <p:cNvSpPr>
             <a:spLocks noGrp="1"/>
           </p:cNvSpPr>
@@ -600,7 +600,7 @@
         <p:spPr>
           <a:xfrm>
             <a:off x="685800" y="1143000"/>
-            <a:ext cx="5484600" cy="3084480"/>
+            <a:ext cx="5484240" cy="3084120"/>
           </a:xfrm>
           <a:prstGeom prst="rect">
             <a:avLst/>
@@ -634,7 +634,7 @@
       </p:grpSpPr>
       <p:sp>
         <p:nvSpPr>
-          <p:cNvPr id="152" name="PlaceHolder 1"/>
+          <p:cNvPr id="153" name="PlaceHolder 1"/>
           <p:cNvSpPr>
             <a:spLocks noGrp="1"/>
           </p:cNvSpPr>
@@ -645,7 +645,7 @@
         <p:spPr>
           <a:xfrm>
             <a:off x="685800" y="4400640"/>
-            <a:ext cx="5484600" cy="3598920"/>
+            <a:ext cx="5484240" cy="3598560"/>
           </a:xfrm>
           <a:prstGeom prst="rect">
             <a:avLst/>
@@ -694,7 +694,7 @@
       </p:sp>
       <p:sp>
         <p:nvSpPr>
-          <p:cNvPr id="153" name="PlaceHolder 2"/>
+          <p:cNvPr id="154" name="PlaceHolder 2"/>
           <p:cNvSpPr>
             <a:spLocks noGrp="1"/>
           </p:cNvSpPr>
@@ -705,7 +705,7 @@
         <p:spPr>
           <a:xfrm>
             <a:off x="685800" y="1143000"/>
-            <a:ext cx="5484600" cy="3084480"/>
+            <a:ext cx="5484240" cy="3084120"/>
           </a:xfrm>
           <a:prstGeom prst="rect">
             <a:avLst/>
@@ -739,7 +739,7 @@
       </p:grpSpPr>
       <p:sp>
         <p:nvSpPr>
-          <p:cNvPr id="154" name="PlaceHolder 1"/>
+          <p:cNvPr id="155" name="PlaceHolder 1"/>
           <p:cNvSpPr>
             <a:spLocks noGrp="1"/>
           </p:cNvSpPr>
@@ -750,7 +750,7 @@
         <p:spPr>
           <a:xfrm>
             <a:off x="685800" y="4400640"/>
-            <a:ext cx="5484600" cy="3598920"/>
+            <a:ext cx="5484240" cy="3598560"/>
           </a:xfrm>
           <a:prstGeom prst="rect">
             <a:avLst/>
@@ -799,7 +799,7 @@
       </p:sp>
       <p:sp>
         <p:nvSpPr>
-          <p:cNvPr id="155" name="PlaceHolder 2"/>
+          <p:cNvPr id="156" name="PlaceHolder 2"/>
           <p:cNvSpPr>
             <a:spLocks noGrp="1"/>
           </p:cNvSpPr>
@@ -810,7 +810,7 @@
         <p:spPr>
           <a:xfrm>
             <a:off x="685800" y="1143000"/>
-            <a:ext cx="5484600" cy="3084480"/>
+            <a:ext cx="5484240" cy="3084120"/>
           </a:xfrm>
           <a:prstGeom prst="rect">
             <a:avLst/>
@@ -844,7 +844,7 @@
       </p:grpSpPr>
       <p:sp>
         <p:nvSpPr>
-          <p:cNvPr id="134" name="PlaceHolder 1"/>
+          <p:cNvPr id="135" name="PlaceHolder 1"/>
           <p:cNvSpPr>
             <a:spLocks noGrp="1"/>
           </p:cNvSpPr>
@@ -855,7 +855,7 @@
         <p:spPr>
           <a:xfrm>
             <a:off x="685800" y="4400640"/>
-            <a:ext cx="5484600" cy="3598920"/>
+            <a:ext cx="5484240" cy="3598560"/>
           </a:xfrm>
           <a:prstGeom prst="rect">
             <a:avLst/>
@@ -904,7 +904,7 @@
       </p:sp>
       <p:sp>
         <p:nvSpPr>
-          <p:cNvPr id="135" name="PlaceHolder 2"/>
+          <p:cNvPr id="136" name="PlaceHolder 2"/>
           <p:cNvSpPr>
             <a:spLocks noGrp="1"/>
           </p:cNvSpPr>
@@ -915,7 +915,7 @@
         <p:spPr>
           <a:xfrm>
             <a:off x="685800" y="1143000"/>
-            <a:ext cx="5484600" cy="3084480"/>
+            <a:ext cx="5484240" cy="3084120"/>
           </a:xfrm>
           <a:prstGeom prst="rect">
             <a:avLst/>
@@ -949,7 +949,7 @@
       </p:grpSpPr>
       <p:sp>
         <p:nvSpPr>
-          <p:cNvPr id="136" name="PlaceHolder 1"/>
+          <p:cNvPr id="137" name="PlaceHolder 1"/>
           <p:cNvSpPr>
             <a:spLocks noGrp="1"/>
           </p:cNvSpPr>
@@ -960,7 +960,7 @@
         <p:spPr>
           <a:xfrm>
             <a:off x="685800" y="4400640"/>
-            <a:ext cx="5484600" cy="3598920"/>
+            <a:ext cx="5484240" cy="3598560"/>
           </a:xfrm>
           <a:prstGeom prst="rect">
             <a:avLst/>
@@ -1009,7 +1009,7 @@
       </p:sp>
       <p:sp>
         <p:nvSpPr>
-          <p:cNvPr id="137" name="PlaceHolder 2"/>
+          <p:cNvPr id="138" name="PlaceHolder 2"/>
           <p:cNvSpPr>
             <a:spLocks noGrp="1"/>
           </p:cNvSpPr>
@@ -1020,7 +1020,7 @@
         <p:spPr>
           <a:xfrm>
             <a:off x="685800" y="1143000"/>
-            <a:ext cx="5484600" cy="3084480"/>
+            <a:ext cx="5484240" cy="3084120"/>
           </a:xfrm>
           <a:prstGeom prst="rect">
             <a:avLst/>
@@ -1054,7 +1054,7 @@
       </p:grpSpPr>
       <p:sp>
         <p:nvSpPr>
-          <p:cNvPr id="138" name="PlaceHolder 1"/>
+          <p:cNvPr id="139" name="PlaceHolder 1"/>
           <p:cNvSpPr>
             <a:spLocks noGrp="1"/>
           </p:cNvSpPr>
@@ -1065,7 +1065,7 @@
         <p:spPr>
           <a:xfrm>
             <a:off x="685800" y="4400640"/>
-            <a:ext cx="5484600" cy="3598920"/>
+            <a:ext cx="5484240" cy="3598560"/>
           </a:xfrm>
           <a:prstGeom prst="rect">
             <a:avLst/>
@@ -1114,7 +1114,7 @@
       </p:sp>
       <p:sp>
         <p:nvSpPr>
-          <p:cNvPr id="139" name="PlaceHolder 2"/>
+          <p:cNvPr id="140" name="PlaceHolder 2"/>
           <p:cNvSpPr>
             <a:spLocks noGrp="1"/>
           </p:cNvSpPr>
@@ -1125,7 +1125,7 @@
         <p:spPr>
           <a:xfrm>
             <a:off x="685800" y="1143000"/>
-            <a:ext cx="5484600" cy="3084480"/>
+            <a:ext cx="5484240" cy="3084120"/>
           </a:xfrm>
           <a:prstGeom prst="rect">
             <a:avLst/>
@@ -1159,7 +1159,7 @@
       </p:grpSpPr>
       <p:sp>
         <p:nvSpPr>
-          <p:cNvPr id="140" name="PlaceHolder 1"/>
+          <p:cNvPr id="141" name="PlaceHolder 1"/>
           <p:cNvSpPr>
             <a:spLocks noGrp="1"/>
           </p:cNvSpPr>
@@ -1170,7 +1170,7 @@
         <p:spPr>
           <a:xfrm>
             <a:off x="685800" y="4400640"/>
-            <a:ext cx="5484600" cy="3598920"/>
+            <a:ext cx="5484240" cy="3598560"/>
           </a:xfrm>
           <a:prstGeom prst="rect">
             <a:avLst/>
@@ -1219,7 +1219,7 @@
       </p:sp>
       <p:sp>
         <p:nvSpPr>
-          <p:cNvPr id="141" name="PlaceHolder 2"/>
+          <p:cNvPr id="142" name="PlaceHolder 2"/>
           <p:cNvSpPr>
             <a:spLocks noGrp="1"/>
           </p:cNvSpPr>
@@ -1230,7 +1230,7 @@
         <p:spPr>
           <a:xfrm>
             <a:off x="685800" y="1143000"/>
-            <a:ext cx="5484600" cy="3084480"/>
+            <a:ext cx="5484240" cy="3084120"/>
           </a:xfrm>
           <a:prstGeom prst="rect">
             <a:avLst/>
@@ -1264,7 +1264,7 @@
       </p:grpSpPr>
       <p:sp>
         <p:nvSpPr>
-          <p:cNvPr id="142" name="PlaceHolder 1"/>
+          <p:cNvPr id="143" name="PlaceHolder 1"/>
           <p:cNvSpPr>
             <a:spLocks noGrp="1"/>
           </p:cNvSpPr>
@@ -1275,7 +1275,7 @@
         <p:spPr>
           <a:xfrm>
             <a:off x="685800" y="4400640"/>
-            <a:ext cx="5484600" cy="3598920"/>
+            <a:ext cx="5484240" cy="3598560"/>
           </a:xfrm>
           <a:prstGeom prst="rect">
             <a:avLst/>
@@ -1324,7 +1324,7 @@
       </p:sp>
       <p:sp>
         <p:nvSpPr>
-          <p:cNvPr id="143" name="PlaceHolder 2"/>
+          <p:cNvPr id="144" name="PlaceHolder 2"/>
           <p:cNvSpPr>
             <a:spLocks noGrp="1"/>
           </p:cNvSpPr>
@@ -1335,7 +1335,7 @@
         <p:spPr>
           <a:xfrm>
             <a:off x="685800" y="1143000"/>
-            <a:ext cx="5484600" cy="3084480"/>
+            <a:ext cx="5484240" cy="3084120"/>
           </a:xfrm>
           <a:prstGeom prst="rect">
             <a:avLst/>
@@ -1369,7 +1369,7 @@
       </p:grpSpPr>
       <p:sp>
         <p:nvSpPr>
-          <p:cNvPr id="144" name="PlaceHolder 1"/>
+          <p:cNvPr id="145" name="PlaceHolder 1"/>
           <p:cNvSpPr>
             <a:spLocks noGrp="1"/>
           </p:cNvSpPr>
@@ -1380,7 +1380,7 @@
         <p:spPr>
           <a:xfrm>
             <a:off x="685800" y="4400640"/>
-            <a:ext cx="5484600" cy="3598920"/>
+            <a:ext cx="5484240" cy="3598560"/>
           </a:xfrm>
           <a:prstGeom prst="rect">
             <a:avLst/>
@@ -1429,7 +1429,7 @@
       </p:sp>
       <p:sp>
         <p:nvSpPr>
-          <p:cNvPr id="145" name="PlaceHolder 2"/>
+          <p:cNvPr id="146" name="PlaceHolder 2"/>
           <p:cNvSpPr>
             <a:spLocks noGrp="1"/>
           </p:cNvSpPr>
@@ -1440,7 +1440,7 @@
         <p:spPr>
           <a:xfrm>
             <a:off x="685800" y="1143000"/>
-            <a:ext cx="5484600" cy="3084480"/>
+            <a:ext cx="5484240" cy="3084120"/>
           </a:xfrm>
           <a:prstGeom prst="rect">
             <a:avLst/>
@@ -1474,7 +1474,7 @@
       </p:grpSpPr>
       <p:sp>
         <p:nvSpPr>
-          <p:cNvPr id="146" name="PlaceHolder 1"/>
+          <p:cNvPr id="147" name="PlaceHolder 1"/>
           <p:cNvSpPr>
             <a:spLocks noGrp="1"/>
           </p:cNvSpPr>
@@ -1485,7 +1485,7 @@
         <p:spPr>
           <a:xfrm>
             <a:off x="685800" y="4400640"/>
-            <a:ext cx="5484600" cy="3598920"/>
+            <a:ext cx="5484240" cy="3598560"/>
           </a:xfrm>
           <a:prstGeom prst="rect">
             <a:avLst/>
@@ -1534,7 +1534,7 @@
       </p:sp>
       <p:sp>
         <p:nvSpPr>
-          <p:cNvPr id="147" name="PlaceHolder 2"/>
+          <p:cNvPr id="148" name="PlaceHolder 2"/>
           <p:cNvSpPr>
             <a:spLocks noGrp="1"/>
           </p:cNvSpPr>
@@ -1545,7 +1545,7 @@
         <p:spPr>
           <a:xfrm>
             <a:off x="685800" y="1143000"/>
-            <a:ext cx="5484600" cy="3084480"/>
+            <a:ext cx="5484240" cy="3084120"/>
           </a:xfrm>
           <a:prstGeom prst="rect">
             <a:avLst/>
@@ -1597,7 +1597,7 @@
         <p:spPr>
           <a:xfrm>
             <a:off x="609480" y="274680"/>
-            <a:ext cx="10971000" cy="1141200"/>
+            <a:ext cx="10970640" cy="1140840"/>
           </a:xfrm>
           <a:prstGeom prst="rect">
             <a:avLst/>
@@ -1656,7 +1656,7 @@
         <p:spPr>
           <a:xfrm>
             <a:off x="609480" y="6356520"/>
-            <a:ext cx="2842920" cy="363240"/>
+            <a:ext cx="2842560" cy="362880"/>
           </a:xfrm>
           <a:prstGeom prst="rect">
             <a:avLst/>
@@ -1734,7 +1734,7 @@
         <p:spPr>
           <a:xfrm>
             <a:off x="4165560" y="6356520"/>
-            <a:ext cx="3858840" cy="363240"/>
+            <a:ext cx="3858480" cy="362880"/>
           </a:xfrm>
           <a:prstGeom prst="rect">
             <a:avLst/>
@@ -1812,7 +1812,7 @@
         <p:spPr>
           <a:xfrm>
             <a:off x="8737560" y="6356520"/>
-            <a:ext cx="2842920" cy="363240"/>
+            <a:ext cx="2842560" cy="362880"/>
           </a:xfrm>
           <a:prstGeom prst="rect">
             <a:avLst/>
@@ -1856,7 +1856,7 @@
                 <a:tab algn="l" pos="0"/>
               </a:tabLst>
             </a:pPr>
-            <a:fld id="{8E5AC567-3B5E-4615-B3B1-F426DEC7A173}" type="slidenum">
+            <a:fld id="{30A08A05-CA3F-4510-8FB8-B49D675922D2}" type="slidenum">
               <a:rPr b="0" lang="pt-BR" sz="1200" strike="noStrike" u="none">
                 <a:solidFill>
                   <a:srgbClr val="888888"/>
@@ -1892,7 +1892,7 @@
         <p:spPr>
           <a:xfrm>
             <a:off x="609480" y="1604520"/>
-            <a:ext cx="10971000" cy="3975840"/>
+            <a:ext cx="10970640" cy="3975480"/>
           </a:xfrm>
           <a:prstGeom prst="rect">
             <a:avLst/>
@@ -2196,7 +2196,7 @@
         <p:spPr>
           <a:xfrm>
             <a:off x="0" y="0"/>
-            <a:ext cx="12190320" cy="5947560"/>
+            <a:ext cx="12189960" cy="5947200"/>
           </a:xfrm>
           <a:prstGeom prst="rect">
             <a:avLst/>
@@ -2220,7 +2220,7 @@
         <p:spPr>
           <a:xfrm>
             <a:off x="609480" y="6356520"/>
-            <a:ext cx="2842920" cy="363240"/>
+            <a:ext cx="2842560" cy="362880"/>
           </a:xfrm>
           <a:prstGeom prst="rect">
             <a:avLst/>
@@ -2298,7 +2298,7 @@
         <p:spPr>
           <a:xfrm>
             <a:off x="4165560" y="6356520"/>
-            <a:ext cx="3858840" cy="363240"/>
+            <a:ext cx="3858480" cy="362880"/>
           </a:xfrm>
           <a:prstGeom prst="rect">
             <a:avLst/>
@@ -2376,7 +2376,7 @@
         <p:spPr>
           <a:xfrm>
             <a:off x="8737560" y="6356520"/>
-            <a:ext cx="2842920" cy="363240"/>
+            <a:ext cx="2842560" cy="362880"/>
           </a:xfrm>
           <a:prstGeom prst="rect">
             <a:avLst/>
@@ -2420,7 +2420,7 @@
                 <a:tab algn="l" pos="0"/>
               </a:tabLst>
             </a:pPr>
-            <a:fld id="{1F7CD69A-7B1F-47D4-A68E-D91DAC6B72C8}" type="slidenum">
+            <a:fld id="{137B5098-764E-4DB6-AACE-8CC7B1BF2D1D}" type="slidenum">
               <a:rPr b="0" lang="pt-BR" sz="1200" strike="noStrike" u="none">
                 <a:solidFill>
                   <a:srgbClr val="888888"/>
@@ -2456,7 +2456,7 @@
         <p:spPr>
           <a:xfrm>
             <a:off x="0" y="5464440"/>
-            <a:ext cx="12190320" cy="1391760"/>
+            <a:ext cx="12189960" cy="1391400"/>
           </a:xfrm>
           <a:prstGeom prst="rect">
             <a:avLst/>
@@ -2510,7 +2510,7 @@
         <p:spPr>
           <a:xfrm>
             <a:off x="0" y="0"/>
-            <a:ext cx="12190320" cy="5803560"/>
+            <a:ext cx="12189960" cy="5803200"/>
           </a:xfrm>
           <a:prstGeom prst="rect">
             <a:avLst/>
@@ -2534,7 +2534,7 @@
         <p:spPr>
           <a:xfrm>
             <a:off x="609480" y="6356520"/>
-            <a:ext cx="2842920" cy="363240"/>
+            <a:ext cx="2842560" cy="362880"/>
           </a:xfrm>
           <a:prstGeom prst="rect">
             <a:avLst/>
@@ -2612,7 +2612,7 @@
         <p:spPr>
           <a:xfrm>
             <a:off x="4165560" y="6356520"/>
-            <a:ext cx="3858840" cy="363240"/>
+            <a:ext cx="3858480" cy="362880"/>
           </a:xfrm>
           <a:prstGeom prst="rect">
             <a:avLst/>
@@ -2690,7 +2690,7 @@
         <p:spPr>
           <a:xfrm>
             <a:off x="8737560" y="6356520"/>
-            <a:ext cx="2842920" cy="363240"/>
+            <a:ext cx="2842560" cy="362880"/>
           </a:xfrm>
           <a:prstGeom prst="rect">
             <a:avLst/>
@@ -2734,7 +2734,7 @@
                 <a:tab algn="l" pos="0"/>
               </a:tabLst>
             </a:pPr>
-            <a:fld id="{D7B6BA13-B95E-455E-A759-CB776CEF59A9}" type="slidenum">
+            <a:fld id="{95EAA5F3-85C3-4A29-A54A-BF60E205E78D}" type="slidenum">
               <a:rPr b="0" lang="pt-BR" sz="1200" strike="noStrike" u="none">
                 <a:solidFill>
                   <a:srgbClr val="888888"/>
@@ -2770,7 +2770,7 @@
         <p:spPr>
           <a:xfrm>
             <a:off x="0" y="5465160"/>
-            <a:ext cx="12190320" cy="1391400"/>
+            <a:ext cx="12189960" cy="1391040"/>
           </a:xfrm>
           <a:prstGeom prst="rect">
             <a:avLst/>
@@ -2823,7 +2823,7 @@
         <p:spPr>
           <a:xfrm>
             <a:off x="609480" y="274680"/>
-            <a:ext cx="10971000" cy="1141200"/>
+            <a:ext cx="10970640" cy="1140840"/>
           </a:xfrm>
           <a:prstGeom prst="rect">
             <a:avLst/>
@@ -2882,7 +2882,7 @@
         <p:spPr>
           <a:xfrm>
             <a:off x="609480" y="6356520"/>
-            <a:ext cx="2842920" cy="363240"/>
+            <a:ext cx="2842560" cy="362880"/>
           </a:xfrm>
           <a:prstGeom prst="rect">
             <a:avLst/>
@@ -2960,7 +2960,7 @@
         <p:spPr>
           <a:xfrm>
             <a:off x="4165560" y="6356520"/>
-            <a:ext cx="3858840" cy="363240"/>
+            <a:ext cx="3858480" cy="362880"/>
           </a:xfrm>
           <a:prstGeom prst="rect">
             <a:avLst/>
@@ -3038,7 +3038,7 @@
         <p:spPr>
           <a:xfrm>
             <a:off x="8737560" y="6356520"/>
-            <a:ext cx="2842920" cy="363240"/>
+            <a:ext cx="2842560" cy="362880"/>
           </a:xfrm>
           <a:prstGeom prst="rect">
             <a:avLst/>
@@ -3082,7 +3082,7 @@
                 <a:tab algn="l" pos="0"/>
               </a:tabLst>
             </a:pPr>
-            <a:fld id="{203A56D7-8711-47BD-A276-18153357A54E}" type="slidenum">
+            <a:fld id="{CAE62871-855F-4DE0-BADB-D08510EB3426}" type="slidenum">
               <a:rPr b="0" lang="pt-BR" sz="1200" strike="noStrike" u="none">
                 <a:solidFill>
                   <a:srgbClr val="888888"/>
@@ -3118,7 +3118,7 @@
         <p:spPr>
           <a:xfrm>
             <a:off x="0" y="5464800"/>
-            <a:ext cx="12190320" cy="1391400"/>
+            <a:ext cx="12189960" cy="1391040"/>
           </a:xfrm>
           <a:prstGeom prst="rect">
             <a:avLst/>
@@ -3189,7 +3189,7 @@
         <p:spPr>
           <a:xfrm>
             <a:off x="1080" y="6176160"/>
-            <a:ext cx="12190320" cy="706320"/>
+            <a:ext cx="12189960" cy="705960"/>
           </a:xfrm>
           <a:prstGeom prst="rect">
             <a:avLst/>
@@ -3252,7 +3252,7 @@
         <p:spPr>
           <a:xfrm>
             <a:off x="361080" y="59760"/>
-            <a:ext cx="6991560" cy="858600"/>
+            <a:ext cx="6991200" cy="858240"/>
           </a:xfrm>
           <a:prstGeom prst="rect">
             <a:avLst/>
@@ -3313,7 +3313,7 @@
         <p:spPr>
           <a:xfrm>
             <a:off x="0" y="1211400"/>
-            <a:ext cx="8620200" cy="1800"/>
+            <a:ext cx="8620560" cy="2160"/>
           </a:xfrm>
           <a:prstGeom prst="straightConnector1">
             <a:avLst/>
@@ -3335,7 +3335,7 @@
         <p:spPr>
           <a:xfrm>
             <a:off x="263520" y="6223680"/>
-            <a:ext cx="11500920" cy="552240"/>
+            <a:ext cx="11500560" cy="551880"/>
           </a:xfrm>
           <a:prstGeom prst="rect">
             <a:avLst/>
@@ -3396,7 +3396,7 @@
         <p:spPr>
           <a:xfrm>
             <a:off x="374040" y="516600"/>
-            <a:ext cx="1476720" cy="846720"/>
+            <a:ext cx="1476360" cy="846720"/>
           </a:xfrm>
           <a:prstGeom prst="rect">
             <a:avLst/>
@@ -3461,7 +3461,7 @@
         <p:spPr>
           <a:xfrm>
             <a:off x="8170200" y="80280"/>
-            <a:ext cx="3828600" cy="1428120"/>
+            <a:ext cx="3828240" cy="1427760"/>
           </a:xfrm>
           <a:prstGeom prst="rect">
             <a:avLst/>
@@ -3486,7 +3486,7 @@
         <p:spPr>
           <a:xfrm>
             <a:off x="3678480" y="2407320"/>
-            <a:ext cx="4670280" cy="2041200"/>
+            <a:ext cx="4669920" cy="2040840"/>
           </a:xfrm>
           <a:prstGeom prst="rect">
             <a:avLst/>
@@ -3529,14 +3529,14 @@
       </p:grpSpPr>
       <p:sp>
         <p:nvSpPr>
-          <p:cNvPr id="103" name="Google Shape;284;g2da54814955_3_58"/>
+          <p:cNvPr id="104" name="Google Shape;284;g2da54814955_3_58"/>
           <p:cNvSpPr/>
           <p:nvPr/>
         </p:nvSpPr>
         <p:spPr>
           <a:xfrm>
             <a:off x="1080" y="6156000"/>
-            <a:ext cx="12190320" cy="706320"/>
+            <a:ext cx="12189960" cy="705960"/>
           </a:xfrm>
           <a:prstGeom prst="rect">
             <a:avLst/>
@@ -3592,14 +3592,14 @@
       </p:sp>
       <p:sp>
         <p:nvSpPr>
-          <p:cNvPr id="104" name="Google Shape;285;g2da54814955_3_58"/>
+          <p:cNvPr id="105" name="Google Shape;285;g2da54814955_3_58"/>
           <p:cNvSpPr/>
           <p:nvPr/>
         </p:nvSpPr>
         <p:spPr>
           <a:xfrm>
             <a:off x="361080" y="59760"/>
-            <a:ext cx="6893280" cy="731880"/>
+            <a:ext cx="6892920" cy="731520"/>
           </a:xfrm>
           <a:prstGeom prst="rect">
             <a:avLst/>
@@ -3653,14 +3653,14 @@
       </p:sp>
       <p:cxnSp>
         <p:nvCxnSpPr>
-          <p:cNvPr id="105" name="Google Shape;286;g2da54814955_3_58"/>
+          <p:cNvPr id="106" name="Google Shape;286;g2da54814955_3_58"/>
           <p:cNvCxnSpPr/>
           <p:nvPr/>
         </p:nvCxnSpPr>
         <p:spPr>
           <a:xfrm>
             <a:off x="0" y="1211400"/>
-            <a:ext cx="8620200" cy="1800"/>
+            <a:ext cx="8620560" cy="2160"/>
           </a:xfrm>
           <a:prstGeom prst="straightConnector1">
             <a:avLst/>
@@ -3675,14 +3675,14 @@
       </p:cxnSp>
       <p:sp>
         <p:nvSpPr>
-          <p:cNvPr id="106" name="Google Shape;287;g2da54814955_3_58"/>
+          <p:cNvPr id="107" name="Google Shape;287;g2da54814955_3_58"/>
           <p:cNvSpPr/>
           <p:nvPr/>
         </p:nvSpPr>
         <p:spPr>
           <a:xfrm>
             <a:off x="263520" y="6223680"/>
-            <a:ext cx="11500920" cy="693360"/>
+            <a:ext cx="11500560" cy="693000"/>
           </a:xfrm>
           <a:prstGeom prst="rect">
             <a:avLst/>
@@ -3736,14 +3736,14 @@
       </p:sp>
       <p:sp>
         <p:nvSpPr>
-          <p:cNvPr id="107" name="Google Shape;288;g2da54814955_3_58"/>
+          <p:cNvPr id="108" name="Google Shape;288;g2da54814955_3_58"/>
           <p:cNvSpPr/>
           <p:nvPr/>
         </p:nvSpPr>
         <p:spPr>
           <a:xfrm>
             <a:off x="374040" y="516600"/>
-            <a:ext cx="1476720" cy="693360"/>
+            <a:ext cx="1476360" cy="693000"/>
           </a:xfrm>
           <a:prstGeom prst="rect">
             <a:avLst/>
@@ -3797,7 +3797,7 @@
       </p:sp>
       <p:pic>
         <p:nvPicPr>
-          <p:cNvPr id="108" name="Google Shape;289;g2da54814955_3_58" descr="Resultado de imagem para fatec sÃ£o roque"/>
+          <p:cNvPr id="109" name="Google Shape;289;g2da54814955_3_58" descr="Resultado de imagem para fatec sÃ£o roque"/>
           <p:cNvPicPr/>
           <p:nvPr/>
         </p:nvPicPr>
@@ -3808,7 +3808,7 @@
         <p:spPr>
           <a:xfrm>
             <a:off x="8170200" y="80280"/>
-            <a:ext cx="3828600" cy="1428120"/>
+            <a:ext cx="3828240" cy="1427760"/>
           </a:xfrm>
           <a:prstGeom prst="rect">
             <a:avLst/>
@@ -3821,14 +3821,14 @@
       </p:pic>
       <p:sp>
         <p:nvSpPr>
-          <p:cNvPr id="109" name="Google Shape;291;g2da54814955_3_58"/>
+          <p:cNvPr id="110" name="Google Shape;291;g2da54814955_3_58"/>
           <p:cNvSpPr/>
           <p:nvPr/>
         </p:nvSpPr>
         <p:spPr>
           <a:xfrm>
             <a:off x="374040" y="1360800"/>
-            <a:ext cx="11376360" cy="731160"/>
+            <a:ext cx="11376000" cy="731160"/>
           </a:xfrm>
           <a:prstGeom prst="rect">
             <a:avLst/>
@@ -3882,14 +3882,14 @@
       </p:sp>
       <p:sp>
         <p:nvSpPr>
-          <p:cNvPr id="110" name=""/>
+          <p:cNvPr id="111" name=""/>
           <p:cNvSpPr/>
           <p:nvPr/>
         </p:nvSpPr>
         <p:spPr>
           <a:xfrm>
             <a:off x="1317600" y="1972800"/>
-            <a:ext cx="8941680" cy="4050360"/>
+            <a:ext cx="8941680" cy="4049640"/>
           </a:xfrm>
           <a:prstGeom prst="rect">
             <a:avLst/>
@@ -4105,14 +4105,14 @@
       </p:grpSpPr>
       <p:sp>
         <p:nvSpPr>
-          <p:cNvPr id="111" name="Google Shape;284;g2da54814955_3_ 2"/>
+          <p:cNvPr id="112" name="Google Shape;284;g2da54814955_3_ 2"/>
           <p:cNvSpPr/>
           <p:nvPr/>
         </p:nvSpPr>
         <p:spPr>
           <a:xfrm>
             <a:off x="1080" y="6156000"/>
-            <a:ext cx="12190320" cy="706320"/>
+            <a:ext cx="12189960" cy="705960"/>
           </a:xfrm>
           <a:prstGeom prst="rect">
             <a:avLst/>
@@ -4165,14 +4165,14 @@
       </p:sp>
       <p:sp>
         <p:nvSpPr>
-          <p:cNvPr id="112" name="Google Shape;285;g2da54814955_3_ 3"/>
+          <p:cNvPr id="113" name="Google Shape;285;g2da54814955_3_ 3"/>
           <p:cNvSpPr/>
           <p:nvPr/>
         </p:nvSpPr>
         <p:spPr>
           <a:xfrm>
             <a:off x="361080" y="59760"/>
-            <a:ext cx="6893280" cy="731880"/>
+            <a:ext cx="6892920" cy="731520"/>
           </a:xfrm>
           <a:prstGeom prst="rect">
             <a:avLst/>
@@ -4226,14 +4226,14 @@
       </p:sp>
       <p:cxnSp>
         <p:nvCxnSpPr>
-          <p:cNvPr id="113" name="Google Shape;286;g2da54814955_3_ 3"/>
+          <p:cNvPr id="114" name="Google Shape;286;g2da54814955_3_ 3"/>
           <p:cNvCxnSpPr/>
           <p:nvPr/>
         </p:nvCxnSpPr>
         <p:spPr>
           <a:xfrm>
             <a:off x="0" y="1211400"/>
-            <a:ext cx="8620200" cy="1800"/>
+            <a:ext cx="8620560" cy="2160"/>
           </a:xfrm>
           <a:prstGeom prst="straightConnector1">
             <a:avLst/>
@@ -4248,14 +4248,14 @@
       </p:cxnSp>
       <p:sp>
         <p:nvSpPr>
-          <p:cNvPr id="114" name="Google Shape;287;g2da54814955_3_ 3"/>
+          <p:cNvPr id="115" name="Google Shape;287;g2da54814955_3_ 3"/>
           <p:cNvSpPr/>
           <p:nvPr/>
         </p:nvSpPr>
         <p:spPr>
           <a:xfrm>
             <a:off x="263520" y="6223680"/>
-            <a:ext cx="11500920" cy="693360"/>
+            <a:ext cx="11500560" cy="693000"/>
           </a:xfrm>
           <a:prstGeom prst="rect">
             <a:avLst/>
@@ -4309,14 +4309,14 @@
       </p:sp>
       <p:sp>
         <p:nvSpPr>
-          <p:cNvPr id="115" name="Google Shape;288;g2da54814955_3_ 3"/>
+          <p:cNvPr id="116" name="Google Shape;288;g2da54814955_3_ 3"/>
           <p:cNvSpPr/>
           <p:nvPr/>
         </p:nvSpPr>
         <p:spPr>
           <a:xfrm>
             <a:off x="374040" y="516600"/>
-            <a:ext cx="1476720" cy="693360"/>
+            <a:ext cx="1476360" cy="693000"/>
           </a:xfrm>
           <a:prstGeom prst="rect">
             <a:avLst/>
@@ -4370,7 +4370,7 @@
       </p:sp>
       <p:pic>
         <p:nvPicPr>
-          <p:cNvPr id="116" name="Google Shape;289;g2da54814955_3_ 3" descr="Resultado de imagem para fatec sÃ£o roque"/>
+          <p:cNvPr id="117" name="Google Shape;289;g2da54814955_3_ 3" descr="Resultado de imagem para fatec sÃ£o roque"/>
           <p:cNvPicPr/>
           <p:nvPr/>
         </p:nvPicPr>
@@ -4381,7 +4381,7 @@
         <p:spPr>
           <a:xfrm>
             <a:off x="8170200" y="80280"/>
-            <a:ext cx="3828600" cy="1428120"/>
+            <a:ext cx="3828240" cy="1427760"/>
           </a:xfrm>
           <a:prstGeom prst="rect">
             <a:avLst/>
@@ -4394,14 +4394,14 @@
       </p:pic>
       <p:sp>
         <p:nvSpPr>
-          <p:cNvPr id="117" name="Google Shape;291;g2da54814955_3_ 3"/>
+          <p:cNvPr id="118" name="Google Shape;291;g2da54814955_3_ 3"/>
           <p:cNvSpPr/>
           <p:nvPr/>
         </p:nvSpPr>
         <p:spPr>
           <a:xfrm>
             <a:off x="374040" y="1360800"/>
-            <a:ext cx="11376360" cy="731160"/>
+            <a:ext cx="11376000" cy="731160"/>
           </a:xfrm>
           <a:prstGeom prst="rect">
             <a:avLst/>
@@ -4455,14 +4455,14 @@
       </p:sp>
       <p:sp>
         <p:nvSpPr>
-          <p:cNvPr id="118" name=""/>
+          <p:cNvPr id="119" name=""/>
           <p:cNvSpPr/>
           <p:nvPr/>
         </p:nvSpPr>
         <p:spPr>
           <a:xfrm>
             <a:off x="1620000" y="2375640"/>
-            <a:ext cx="8819280" cy="3041640"/>
+            <a:ext cx="8818920" cy="3041280"/>
           </a:xfrm>
           <a:prstGeom prst="rect">
             <a:avLst/>
@@ -4585,14 +4585,14 @@
       </p:grpSpPr>
       <p:sp>
         <p:nvSpPr>
-          <p:cNvPr id="119" name="Google Shape;284;g2da54814955_3_ 3"/>
+          <p:cNvPr id="120" name="Google Shape;284;g2da54814955_3_ 3"/>
           <p:cNvSpPr/>
           <p:nvPr/>
         </p:nvSpPr>
         <p:spPr>
           <a:xfrm>
             <a:off x="1080" y="6156000"/>
-            <a:ext cx="12190320" cy="706320"/>
+            <a:ext cx="12189960" cy="705960"/>
           </a:xfrm>
           <a:prstGeom prst="rect">
             <a:avLst/>
@@ -4645,14 +4645,14 @@
       </p:sp>
       <p:sp>
         <p:nvSpPr>
-          <p:cNvPr id="120" name="Google Shape;285;g2da54814955_3_ 4"/>
+          <p:cNvPr id="121" name="Google Shape;285;g2da54814955_3_ 4"/>
           <p:cNvSpPr/>
           <p:nvPr/>
         </p:nvSpPr>
         <p:spPr>
           <a:xfrm>
             <a:off x="361080" y="59760"/>
-            <a:ext cx="6893280" cy="731880"/>
+            <a:ext cx="6892920" cy="731520"/>
           </a:xfrm>
           <a:prstGeom prst="rect">
             <a:avLst/>
@@ -4706,14 +4706,14 @@
       </p:sp>
       <p:cxnSp>
         <p:nvCxnSpPr>
-          <p:cNvPr id="121" name="Google Shape;286;g2da54814955_3_ 4"/>
+          <p:cNvPr id="122" name="Google Shape;286;g2da54814955_3_ 4"/>
           <p:cNvCxnSpPr/>
           <p:nvPr/>
         </p:nvCxnSpPr>
         <p:spPr>
           <a:xfrm>
             <a:off x="0" y="1211400"/>
-            <a:ext cx="8620200" cy="1800"/>
+            <a:ext cx="8620560" cy="2160"/>
           </a:xfrm>
           <a:prstGeom prst="straightConnector1">
             <a:avLst/>
@@ -4728,14 +4728,14 @@
       </p:cxnSp>
       <p:sp>
         <p:nvSpPr>
-          <p:cNvPr id="122" name="Google Shape;287;g2da54814955_3_ 4"/>
+          <p:cNvPr id="123" name="Google Shape;287;g2da54814955_3_ 4"/>
           <p:cNvSpPr/>
           <p:nvPr/>
         </p:nvSpPr>
         <p:spPr>
           <a:xfrm>
             <a:off x="263520" y="6223680"/>
-            <a:ext cx="11500920" cy="693360"/>
+            <a:ext cx="11500560" cy="693000"/>
           </a:xfrm>
           <a:prstGeom prst="rect">
             <a:avLst/>
@@ -4789,14 +4789,14 @@
       </p:sp>
       <p:sp>
         <p:nvSpPr>
-          <p:cNvPr id="123" name="Google Shape;288;g2da54814955_3_ 4"/>
+          <p:cNvPr id="124" name="Google Shape;288;g2da54814955_3_ 4"/>
           <p:cNvSpPr/>
           <p:nvPr/>
         </p:nvSpPr>
         <p:spPr>
           <a:xfrm>
             <a:off x="374040" y="516600"/>
-            <a:ext cx="1476720" cy="693360"/>
+            <a:ext cx="1476360" cy="693000"/>
           </a:xfrm>
           <a:prstGeom prst="rect">
             <a:avLst/>
@@ -4850,7 +4850,7 @@
       </p:sp>
       <p:pic>
         <p:nvPicPr>
-          <p:cNvPr id="124" name="Google Shape;289;g2da54814955_3_ 4" descr="Resultado de imagem para fatec sÃ£o roque"/>
+          <p:cNvPr id="125" name="Google Shape;289;g2da54814955_3_ 4" descr="Resultado de imagem para fatec sÃ£o roque"/>
           <p:cNvPicPr/>
           <p:nvPr/>
         </p:nvPicPr>
@@ -4861,7 +4861,7 @@
         <p:spPr>
           <a:xfrm>
             <a:off x="8170200" y="80280"/>
-            <a:ext cx="3828600" cy="1428120"/>
+            <a:ext cx="3828240" cy="1427760"/>
           </a:xfrm>
           <a:prstGeom prst="rect">
             <a:avLst/>
@@ -4874,14 +4874,14 @@
       </p:pic>
       <p:sp>
         <p:nvSpPr>
-          <p:cNvPr id="125" name="Google Shape;291;g2da54814955_3_ 4"/>
+          <p:cNvPr id="126" name="Google Shape;291;g2da54814955_3_ 4"/>
           <p:cNvSpPr/>
           <p:nvPr/>
         </p:nvSpPr>
         <p:spPr>
           <a:xfrm>
             <a:off x="374040" y="1360800"/>
-            <a:ext cx="11376360" cy="731160"/>
+            <a:ext cx="11376000" cy="731160"/>
           </a:xfrm>
           <a:prstGeom prst="rect">
             <a:avLst/>
@@ -4935,14 +4935,14 @@
       </p:sp>
       <p:sp>
         <p:nvSpPr>
-          <p:cNvPr id="126" name=""/>
+          <p:cNvPr id="127" name=""/>
           <p:cNvSpPr/>
           <p:nvPr/>
         </p:nvSpPr>
         <p:spPr>
           <a:xfrm>
             <a:off x="900000" y="2186640"/>
-            <a:ext cx="10799280" cy="2672640"/>
+            <a:ext cx="10798920" cy="2672280"/>
           </a:xfrm>
           <a:prstGeom prst="rect">
             <a:avLst/>
@@ -5077,14 +5077,14 @@
       </p:grpSpPr>
       <p:sp>
         <p:nvSpPr>
-          <p:cNvPr id="127" name="Google Shape;297;g2da54814955_3_80"/>
+          <p:cNvPr id="128" name="Google Shape;297;g2da54814955_3_80"/>
           <p:cNvSpPr/>
           <p:nvPr/>
         </p:nvSpPr>
         <p:spPr>
           <a:xfrm>
             <a:off x="1080" y="6156000"/>
-            <a:ext cx="12190320" cy="706320"/>
+            <a:ext cx="12189960" cy="705960"/>
           </a:xfrm>
           <a:prstGeom prst="rect">
             <a:avLst/>
@@ -5140,14 +5140,14 @@
       </p:sp>
       <p:sp>
         <p:nvSpPr>
-          <p:cNvPr id="128" name="Google Shape;298;g2da54814955_3_80"/>
+          <p:cNvPr id="129" name="Google Shape;298;g2da54814955_3_80"/>
           <p:cNvSpPr/>
           <p:nvPr/>
         </p:nvSpPr>
         <p:spPr>
           <a:xfrm>
             <a:off x="361080" y="59760"/>
-            <a:ext cx="6814440" cy="731880"/>
+            <a:ext cx="6814080" cy="731520"/>
           </a:xfrm>
           <a:prstGeom prst="rect">
             <a:avLst/>
@@ -5201,14 +5201,14 @@
       </p:sp>
       <p:cxnSp>
         <p:nvCxnSpPr>
-          <p:cNvPr id="129" name="Google Shape;299;g2da54814955_3_80"/>
+          <p:cNvPr id="130" name="Google Shape;299;g2da54814955_3_80"/>
           <p:cNvCxnSpPr/>
           <p:nvPr/>
         </p:nvCxnSpPr>
         <p:spPr>
           <a:xfrm>
             <a:off x="0" y="1211400"/>
-            <a:ext cx="8620200" cy="1800"/>
+            <a:ext cx="8620560" cy="2160"/>
           </a:xfrm>
           <a:prstGeom prst="straightConnector1">
             <a:avLst/>
@@ -5223,14 +5223,14 @@
       </p:cxnSp>
       <p:sp>
         <p:nvSpPr>
-          <p:cNvPr id="130" name="Google Shape;300;g2da54814955_3_80"/>
+          <p:cNvPr id="131" name="Google Shape;300;g2da54814955_3_80"/>
           <p:cNvSpPr/>
           <p:nvPr/>
         </p:nvSpPr>
         <p:spPr>
           <a:xfrm>
             <a:off x="263520" y="6223680"/>
-            <a:ext cx="11500920" cy="693360"/>
+            <a:ext cx="11500560" cy="693000"/>
           </a:xfrm>
           <a:prstGeom prst="rect">
             <a:avLst/>
@@ -5284,14 +5284,14 @@
       </p:sp>
       <p:sp>
         <p:nvSpPr>
-          <p:cNvPr id="131" name="Google Shape;301;g2da54814955_3_80"/>
+          <p:cNvPr id="132" name="Google Shape;301;g2da54814955_3_80"/>
           <p:cNvSpPr/>
           <p:nvPr/>
         </p:nvSpPr>
         <p:spPr>
           <a:xfrm>
             <a:off x="374040" y="516600"/>
-            <a:ext cx="1476720" cy="693360"/>
+            <a:ext cx="1476360" cy="693000"/>
           </a:xfrm>
           <a:prstGeom prst="rect">
             <a:avLst/>
@@ -5345,7 +5345,7 @@
       </p:sp>
       <p:pic>
         <p:nvPicPr>
-          <p:cNvPr id="132" name="Google Shape;302;g2da54814955_3_80" descr="Resultado de imagem para fatec sÃ£o roque"/>
+          <p:cNvPr id="133" name="Google Shape;302;g2da54814955_3_80" descr="Resultado de imagem para fatec sÃ£o roque"/>
           <p:cNvPicPr/>
           <p:nvPr/>
         </p:nvPicPr>
@@ -5356,7 +5356,7 @@
         <p:spPr>
           <a:xfrm>
             <a:off x="8170200" y="80280"/>
-            <a:ext cx="3828600" cy="1428120"/>
+            <a:ext cx="3828240" cy="1427760"/>
           </a:xfrm>
           <a:prstGeom prst="rect">
             <a:avLst/>
@@ -5369,14 +5369,14 @@
       </p:pic>
       <p:sp>
         <p:nvSpPr>
-          <p:cNvPr id="133" name="Google Shape;303;g2da54814955_3_80"/>
+          <p:cNvPr id="134" name="Google Shape;303;g2da54814955_3_80"/>
           <p:cNvSpPr/>
           <p:nvPr/>
         </p:nvSpPr>
         <p:spPr>
           <a:xfrm>
             <a:off x="408600" y="3085200"/>
-            <a:ext cx="11352960" cy="844920"/>
+            <a:ext cx="11352600" cy="844560"/>
           </a:xfrm>
           <a:prstGeom prst="rect">
             <a:avLst/>
@@ -5467,7 +5467,7 @@
         <p:spPr>
           <a:xfrm>
             <a:off x="1080" y="6186960"/>
-            <a:ext cx="12190320" cy="706320"/>
+            <a:ext cx="12189960" cy="705960"/>
           </a:xfrm>
           <a:prstGeom prst="rect">
             <a:avLst/>
@@ -5530,7 +5530,7 @@
         <p:spPr>
           <a:xfrm>
             <a:off x="361080" y="59760"/>
-            <a:ext cx="6991560" cy="858600"/>
+            <a:ext cx="6991200" cy="858240"/>
           </a:xfrm>
           <a:prstGeom prst="rect">
             <a:avLst/>
@@ -5591,7 +5591,7 @@
         <p:spPr>
           <a:xfrm>
             <a:off x="0" y="1211400"/>
-            <a:ext cx="8620200" cy="1800"/>
+            <a:ext cx="8620560" cy="2160"/>
           </a:xfrm>
           <a:prstGeom prst="straightConnector1">
             <a:avLst/>
@@ -5613,7 +5613,7 @@
         <p:spPr>
           <a:xfrm>
             <a:off x="360000" y="4500000"/>
-            <a:ext cx="3598920" cy="898920"/>
+            <a:ext cx="3598560" cy="898560"/>
           </a:xfrm>
           <a:prstGeom prst="rect">
             <a:avLst/>
@@ -5704,7 +5704,7 @@
         <p:spPr>
           <a:xfrm>
             <a:off x="263520" y="6223680"/>
-            <a:ext cx="11500920" cy="693360"/>
+            <a:ext cx="11500560" cy="693000"/>
           </a:xfrm>
           <a:prstGeom prst="rect">
             <a:avLst/>
@@ -5765,7 +5765,7 @@
         <p:spPr>
           <a:xfrm>
             <a:off x="374040" y="516600"/>
-            <a:ext cx="1476720" cy="693360"/>
+            <a:ext cx="1476360" cy="693000"/>
           </a:xfrm>
           <a:prstGeom prst="rect">
             <a:avLst/>
@@ -5830,7 +5830,7 @@
         <p:spPr>
           <a:xfrm>
             <a:off x="8170200" y="80280"/>
-            <a:ext cx="3828600" cy="1428120"/>
+            <a:ext cx="3828240" cy="1427760"/>
           </a:xfrm>
           <a:prstGeom prst="rect">
             <a:avLst/>
@@ -5854,8 +5854,8 @@
         </p:blipFill>
         <p:spPr>
           <a:xfrm>
-            <a:off x="540000" y="1800000"/>
-            <a:ext cx="1936080" cy="2777040"/>
+            <a:off x="468000" y="1800000"/>
+            <a:ext cx="1935720" cy="2776680"/>
           </a:xfrm>
           <a:prstGeom prst="rect">
             <a:avLst/>
@@ -6113,8 +6113,8 @@
         </p:nvSpPr>
         <p:spPr>
           <a:xfrm>
-            <a:off x="3886560" y="4431600"/>
-            <a:ext cx="3132360" cy="751320"/>
+            <a:off x="3960000" y="4500000"/>
+            <a:ext cx="3888000" cy="791280"/>
           </a:xfrm>
           <a:prstGeom prst="rect">
             <a:avLst/>
@@ -6141,7 +6141,7 @@
               </a:lnSpc>
             </a:pPr>
             <a:r>
-              <a:rPr b="1" lang="pt-BR" sz="3200" strike="noStrike" u="none">
+              <a:rPr b="1" lang="pt-BR" sz="2600" strike="noStrike" u="none">
                 <a:solidFill>
                   <a:schemeClr val="dk1"/>
                 </a:solidFill>
@@ -6152,7 +6152,7 @@
               </a:rPr>
               <a:t>Vinícius Venâncio</a:t>
             </a:r>
-            <a:endParaRPr b="0" lang="pt-BR" sz="3200" strike="noStrike" u="none">
+            <a:endParaRPr b="0" lang="pt-BR" sz="2600" strike="noStrike" u="none">
               <a:solidFill>
                 <a:srgbClr val="000000"/>
               </a:solidFill>
@@ -6177,7 +6177,7 @@
                 <a:latin typeface="Calibri"/>
                 <a:ea typeface="Calibri"/>
               </a:rPr>
-              <a:t>@fatec.sp.gov.br</a:t>
+              <a:t>vinicius.venancio@fatec.sp.gov.br</a:t>
             </a:r>
             <a:endParaRPr b="0" lang="pt-BR" sz="2000" strike="noStrike" u="none">
               <a:solidFill>
@@ -6190,6 +6190,31 @@
           </a:p>
         </p:txBody>
       </p:sp>
+      <p:pic>
+        <p:nvPicPr>
+          <p:cNvPr id="43" name="" descr=""/>
+          <p:cNvPicPr/>
+          <p:nvPr/>
+        </p:nvPicPr>
+        <p:blipFill>
+          <a:blip r:embed="rId3"/>
+          <a:srcRect l="0" t="22930" r="6058" b="9391"/>
+          <a:stretch/>
+        </p:blipFill>
+        <p:spPr>
+          <a:xfrm>
+            <a:off x="4032000" y="1800000"/>
+            <a:ext cx="2136600" cy="2795400"/>
+          </a:xfrm>
+          <a:prstGeom prst="rect">
+            <a:avLst/>
+          </a:prstGeom>
+          <a:noFill/>
+          <a:ln w="0">
+            <a:noFill/>
+          </a:ln>
+        </p:spPr>
+      </p:pic>
     </p:spTree>
   </p:cSld>
   <mc:AlternateContent>
@@ -6222,14 +6247,14 @@
       </p:grpSpPr>
       <p:sp>
         <p:nvSpPr>
-          <p:cNvPr id="43" name="Google Shape;97;g2da54814955_1_4"/>
+          <p:cNvPr id="44" name="Google Shape;97;g2da54814955_1_4"/>
           <p:cNvSpPr/>
           <p:nvPr/>
         </p:nvSpPr>
         <p:spPr>
           <a:xfrm>
             <a:off x="1080" y="6187680"/>
-            <a:ext cx="12190320" cy="706320"/>
+            <a:ext cx="12189960" cy="705960"/>
           </a:xfrm>
           <a:prstGeom prst="rect">
             <a:avLst/>
@@ -6285,14 +6310,14 @@
       </p:sp>
       <p:sp>
         <p:nvSpPr>
-          <p:cNvPr id="44" name="Google Shape;98;g2da54814955_1_4"/>
+          <p:cNvPr id="45" name="Google Shape;98;g2da54814955_1_4"/>
           <p:cNvSpPr/>
           <p:nvPr/>
         </p:nvSpPr>
         <p:spPr>
           <a:xfrm>
             <a:off x="361080" y="59760"/>
-            <a:ext cx="7050600" cy="731880"/>
+            <a:ext cx="7050240" cy="731520"/>
           </a:xfrm>
           <a:prstGeom prst="rect">
             <a:avLst/>
@@ -6346,14 +6371,14 @@
       </p:sp>
       <p:cxnSp>
         <p:nvCxnSpPr>
-          <p:cNvPr id="45" name="Google Shape;99;g2da54814955_1_4"/>
+          <p:cNvPr id="46" name="Google Shape;99;g2da54814955_1_4"/>
           <p:cNvCxnSpPr/>
           <p:nvPr/>
         </p:nvCxnSpPr>
         <p:spPr>
           <a:xfrm>
             <a:off x="0" y="1211400"/>
-            <a:ext cx="8620200" cy="1800"/>
+            <a:ext cx="8620560" cy="2160"/>
           </a:xfrm>
           <a:prstGeom prst="straightConnector1">
             <a:avLst/>
@@ -6368,14 +6393,14 @@
       </p:cxnSp>
       <p:sp>
         <p:nvSpPr>
-          <p:cNvPr id="46" name="Google Shape;100;g2da54814955_1_4"/>
+          <p:cNvPr id="47" name="Google Shape;100;g2da54814955_1_4"/>
           <p:cNvSpPr/>
           <p:nvPr/>
         </p:nvSpPr>
         <p:spPr>
           <a:xfrm>
             <a:off x="263520" y="6223680"/>
-            <a:ext cx="11500920" cy="693360"/>
+            <a:ext cx="11500560" cy="693000"/>
           </a:xfrm>
           <a:prstGeom prst="rect">
             <a:avLst/>
@@ -6429,14 +6454,14 @@
       </p:sp>
       <p:sp>
         <p:nvSpPr>
-          <p:cNvPr id="47" name="Google Shape;101;g2da54814955_1_4"/>
+          <p:cNvPr id="48" name="Google Shape;101;g2da54814955_1_4"/>
           <p:cNvSpPr/>
           <p:nvPr/>
         </p:nvSpPr>
         <p:spPr>
           <a:xfrm>
             <a:off x="374040" y="516600"/>
-            <a:ext cx="1476720" cy="693360"/>
+            <a:ext cx="1476360" cy="693000"/>
           </a:xfrm>
           <a:prstGeom prst="rect">
             <a:avLst/>
@@ -6490,7 +6515,7 @@
       </p:sp>
       <p:pic>
         <p:nvPicPr>
-          <p:cNvPr id="48" name="Google Shape;102;g2da54814955_1_4" descr="Resultado de imagem para fatec sÃ£o roque"/>
+          <p:cNvPr id="49" name="Google Shape;102;g2da54814955_1_4" descr="Resultado de imagem para fatec sÃ£o roque"/>
           <p:cNvPicPr/>
           <p:nvPr/>
         </p:nvPicPr>
@@ -6501,7 +6526,7 @@
         <p:spPr>
           <a:xfrm>
             <a:off x="8170200" y="80280"/>
-            <a:ext cx="3828600" cy="1428120"/>
+            <a:ext cx="3828240" cy="1427760"/>
           </a:xfrm>
           <a:prstGeom prst="rect">
             <a:avLst/>
@@ -6514,14 +6539,14 @@
       </p:pic>
       <p:sp>
         <p:nvSpPr>
-          <p:cNvPr id="49" name="Google Shape;104;g2da54814955_1_4"/>
+          <p:cNvPr id="50" name="Google Shape;104;g2da54814955_1_4"/>
           <p:cNvSpPr/>
           <p:nvPr/>
         </p:nvSpPr>
         <p:spPr>
           <a:xfrm>
             <a:off x="374040" y="1360800"/>
-            <a:ext cx="7794360" cy="731160"/>
+            <a:ext cx="7794000" cy="731160"/>
           </a:xfrm>
           <a:prstGeom prst="rect">
             <a:avLst/>
@@ -6575,14 +6600,14 @@
       </p:sp>
       <p:sp>
         <p:nvSpPr>
-          <p:cNvPr id="50" name=""/>
+          <p:cNvPr id="51" name=""/>
           <p:cNvSpPr/>
           <p:nvPr/>
         </p:nvSpPr>
         <p:spPr>
           <a:xfrm>
             <a:off x="360000" y="1980720"/>
-            <a:ext cx="11519280" cy="3779280"/>
+            <a:ext cx="11518920" cy="3778920"/>
           </a:xfrm>
           <a:prstGeom prst="rect">
             <a:avLst/>
@@ -6744,14 +6769,14 @@
       </p:grpSpPr>
       <p:sp>
         <p:nvSpPr>
-          <p:cNvPr id="51" name="Google Shape;112;g2da54814955_1_37"/>
+          <p:cNvPr id="52" name="Google Shape;112;g2da54814955_1_37"/>
           <p:cNvSpPr/>
           <p:nvPr/>
         </p:nvSpPr>
         <p:spPr>
           <a:xfrm>
             <a:off x="0" y="6186960"/>
-            <a:ext cx="12191400" cy="706320"/>
+            <a:ext cx="12191040" cy="705960"/>
           </a:xfrm>
           <a:prstGeom prst="rect">
             <a:avLst/>
@@ -6807,14 +6832,14 @@
       </p:sp>
       <p:sp>
         <p:nvSpPr>
-          <p:cNvPr id="52" name="Google Shape;113;g2da54814955_1_37"/>
+          <p:cNvPr id="53" name="Google Shape;113;g2da54814955_1_37"/>
           <p:cNvSpPr/>
           <p:nvPr/>
         </p:nvSpPr>
         <p:spPr>
           <a:xfrm>
             <a:off x="361080" y="59760"/>
-            <a:ext cx="7021080" cy="731880"/>
+            <a:ext cx="7020720" cy="731520"/>
           </a:xfrm>
           <a:prstGeom prst="rect">
             <a:avLst/>
@@ -6868,14 +6893,14 @@
       </p:sp>
       <p:cxnSp>
         <p:nvCxnSpPr>
-          <p:cNvPr id="53" name="Google Shape;114;g2da54814955_1_37"/>
+          <p:cNvPr id="54" name="Google Shape;114;g2da54814955_1_37"/>
           <p:cNvCxnSpPr/>
           <p:nvPr/>
         </p:nvCxnSpPr>
         <p:spPr>
           <a:xfrm>
             <a:off x="0" y="1211400"/>
-            <a:ext cx="8620200" cy="1800"/>
+            <a:ext cx="8620560" cy="2160"/>
           </a:xfrm>
           <a:prstGeom prst="straightConnector1">
             <a:avLst/>
@@ -6890,14 +6915,14 @@
       </p:cxnSp>
       <p:sp>
         <p:nvSpPr>
-          <p:cNvPr id="54" name="Google Shape;115;g2da54814955_1_37"/>
+          <p:cNvPr id="55" name="Google Shape;115;g2da54814955_1_37"/>
           <p:cNvSpPr/>
           <p:nvPr/>
         </p:nvSpPr>
         <p:spPr>
           <a:xfrm>
             <a:off x="263520" y="6223680"/>
-            <a:ext cx="11500920" cy="693360"/>
+            <a:ext cx="11500560" cy="693000"/>
           </a:xfrm>
           <a:prstGeom prst="rect">
             <a:avLst/>
@@ -6951,14 +6976,14 @@
       </p:sp>
       <p:sp>
         <p:nvSpPr>
-          <p:cNvPr id="55" name="Google Shape;116;g2da54814955_1_37"/>
+          <p:cNvPr id="56" name="Google Shape;116;g2da54814955_1_37"/>
           <p:cNvSpPr/>
           <p:nvPr/>
         </p:nvSpPr>
         <p:spPr>
           <a:xfrm>
             <a:off x="374040" y="516600"/>
-            <a:ext cx="1476720" cy="693360"/>
+            <a:ext cx="1476360" cy="693000"/>
           </a:xfrm>
           <a:prstGeom prst="rect">
             <a:avLst/>
@@ -7012,7 +7037,7 @@
       </p:sp>
       <p:pic>
         <p:nvPicPr>
-          <p:cNvPr id="56" name="Google Shape;117;g2da54814955_1_37" descr="Resultado de imagem para fatec sÃ£o roque"/>
+          <p:cNvPr id="57" name="Google Shape;117;g2da54814955_1_37" descr="Resultado de imagem para fatec sÃ£o roque"/>
           <p:cNvPicPr/>
           <p:nvPr/>
         </p:nvPicPr>
@@ -7023,7 +7048,7 @@
         <p:spPr>
           <a:xfrm>
             <a:off x="8170200" y="80280"/>
-            <a:ext cx="3828600" cy="1428120"/>
+            <a:ext cx="3828240" cy="1427760"/>
           </a:xfrm>
           <a:prstGeom prst="rect">
             <a:avLst/>
@@ -7036,14 +7061,14 @@
       </p:pic>
       <p:sp>
         <p:nvSpPr>
-          <p:cNvPr id="57" name="Google Shape;119;g2da54814955_1_37"/>
+          <p:cNvPr id="58" name="Google Shape;119;g2da54814955_1_37"/>
           <p:cNvSpPr/>
           <p:nvPr/>
         </p:nvSpPr>
         <p:spPr>
           <a:xfrm>
             <a:off x="374040" y="1360800"/>
-            <a:ext cx="7794360" cy="731160"/>
+            <a:ext cx="7794000" cy="731160"/>
           </a:xfrm>
           <a:prstGeom prst="rect">
             <a:avLst/>
@@ -7097,14 +7122,14 @@
       </p:sp>
       <p:sp>
         <p:nvSpPr>
-          <p:cNvPr id="58" name=""/>
+          <p:cNvPr id="59" name=""/>
           <p:cNvSpPr/>
           <p:nvPr/>
         </p:nvSpPr>
         <p:spPr>
           <a:xfrm>
             <a:off x="263520" y="1800000"/>
-            <a:ext cx="6036480" cy="4643280"/>
+            <a:ext cx="6036120" cy="4643280"/>
           </a:xfrm>
           <a:prstGeom prst="rect">
             <a:avLst/>
@@ -7188,23 +7213,29 @@
       </p:sp>
       <p:sp>
         <p:nvSpPr>
-          <p:cNvPr id="59" name=""/>
-          <p:cNvSpPr txBox="1"/>
+          <p:cNvPr id="60" name=""/>
+          <p:cNvSpPr/>
           <p:nvPr/>
         </p:nvSpPr>
         <p:spPr>
           <a:xfrm>
             <a:off x="5760000" y="1800000"/>
-            <a:ext cx="5760000" cy="4285800"/>
-          </a:xfrm>
-          <a:prstGeom prst="rect">
-            <a:avLst/>
-          </a:prstGeom>
-          <a:noFill/>
-          <a:ln w="0">
-            <a:noFill/>
-          </a:ln>
-        </p:spPr>
+            <a:ext cx="5759640" cy="4285440"/>
+          </a:xfrm>
+          <a:prstGeom prst="rect">
+            <a:avLst/>
+          </a:prstGeom>
+          <a:noFill/>
+          <a:ln w="0">
+            <a:noFill/>
+          </a:ln>
+        </p:spPr>
+        <p:style>
+          <a:lnRef idx="0"/>
+          <a:fillRef idx="0"/>
+          <a:effectRef idx="0"/>
+          <a:fontRef idx="minor"/>
+        </p:style>
         <p:txBody>
           <a:bodyPr lIns="90000" rIns="90000" tIns="45000" bIns="45000" anchor="t" anchorCtr="1">
             <a:spAutoFit/>
@@ -7351,14 +7382,14 @@
       </p:grpSpPr>
       <p:sp>
         <p:nvSpPr>
-          <p:cNvPr id="60" name="Google Shape;124;g2da54814955_3_5"/>
+          <p:cNvPr id="61" name="Google Shape;124;g2da54814955_3_5"/>
           <p:cNvSpPr/>
           <p:nvPr/>
         </p:nvSpPr>
         <p:spPr>
           <a:xfrm>
             <a:off x="0" y="6246720"/>
-            <a:ext cx="12191400" cy="646560"/>
+            <a:ext cx="12191040" cy="646200"/>
           </a:xfrm>
           <a:prstGeom prst="rect">
             <a:avLst/>
@@ -7414,14 +7445,14 @@
       </p:sp>
       <p:sp>
         <p:nvSpPr>
-          <p:cNvPr id="61" name="Google Shape;125;g2da54814955_3_5"/>
+          <p:cNvPr id="62" name="Google Shape;125;g2da54814955_3_5"/>
           <p:cNvSpPr/>
           <p:nvPr/>
         </p:nvSpPr>
         <p:spPr>
           <a:xfrm>
             <a:off x="361080" y="59760"/>
-            <a:ext cx="7168680" cy="731880"/>
+            <a:ext cx="7168320" cy="731520"/>
           </a:xfrm>
           <a:prstGeom prst="rect">
             <a:avLst/>
@@ -7475,14 +7506,14 @@
       </p:sp>
       <p:cxnSp>
         <p:nvCxnSpPr>
-          <p:cNvPr id="62" name="Google Shape;126;g2da54814955_3_5"/>
+          <p:cNvPr id="63" name="Google Shape;126;g2da54814955_3_5"/>
           <p:cNvCxnSpPr/>
           <p:nvPr/>
         </p:nvCxnSpPr>
         <p:spPr>
           <a:xfrm>
             <a:off x="0" y="1211400"/>
-            <a:ext cx="8620200" cy="1800"/>
+            <a:ext cx="8620560" cy="2160"/>
           </a:xfrm>
           <a:prstGeom prst="straightConnector1">
             <a:avLst/>
@@ -7497,14 +7528,14 @@
       </p:cxnSp>
       <p:sp>
         <p:nvSpPr>
-          <p:cNvPr id="63" name="Google Shape;127;g2da54814955_3_5"/>
+          <p:cNvPr id="64" name="Google Shape;127;g2da54814955_3_5"/>
           <p:cNvSpPr/>
           <p:nvPr/>
         </p:nvSpPr>
         <p:spPr>
           <a:xfrm>
             <a:off x="263520" y="6236640"/>
-            <a:ext cx="11500920" cy="693360"/>
+            <a:ext cx="11500560" cy="693000"/>
           </a:xfrm>
           <a:prstGeom prst="rect">
             <a:avLst/>
@@ -7558,14 +7589,14 @@
       </p:sp>
       <p:sp>
         <p:nvSpPr>
-          <p:cNvPr id="64" name="Google Shape;128;g2da54814955_3_5"/>
+          <p:cNvPr id="65" name="Google Shape;128;g2da54814955_3_5"/>
           <p:cNvSpPr/>
           <p:nvPr/>
         </p:nvSpPr>
         <p:spPr>
           <a:xfrm>
             <a:off x="374040" y="516600"/>
-            <a:ext cx="1476720" cy="693360"/>
+            <a:ext cx="1476360" cy="693000"/>
           </a:xfrm>
           <a:prstGeom prst="rect">
             <a:avLst/>
@@ -7619,7 +7650,7 @@
       </p:sp>
       <p:pic>
         <p:nvPicPr>
-          <p:cNvPr id="65" name="Google Shape;129;g2da54814955_3_5" descr="Resultado de imagem para fatec sÃ£o roque"/>
+          <p:cNvPr id="66" name="Google Shape;129;g2da54814955_3_5" descr="Resultado de imagem para fatec sÃ£o roque"/>
           <p:cNvPicPr/>
           <p:nvPr/>
         </p:nvPicPr>
@@ -7630,7 +7661,7 @@
         <p:spPr>
           <a:xfrm>
             <a:off x="8170200" y="80280"/>
-            <a:ext cx="3828600" cy="1428120"/>
+            <a:ext cx="3828240" cy="1427760"/>
           </a:xfrm>
           <a:prstGeom prst="rect">
             <a:avLst/>
@@ -7643,14 +7674,14 @@
       </p:pic>
       <p:sp>
         <p:nvSpPr>
-          <p:cNvPr id="66" name="Google Shape;131;g2da54814955_3_5"/>
+          <p:cNvPr id="67" name="Google Shape;131;g2da54814955_3_5"/>
           <p:cNvSpPr/>
           <p:nvPr/>
         </p:nvSpPr>
         <p:spPr>
           <a:xfrm>
             <a:off x="374040" y="1360800"/>
-            <a:ext cx="7794360" cy="731160"/>
+            <a:ext cx="7794000" cy="731160"/>
           </a:xfrm>
           <a:prstGeom prst="rect">
             <a:avLst/>
@@ -7704,14 +7735,14 @@
       </p:sp>
       <p:sp>
         <p:nvSpPr>
-          <p:cNvPr id="67" name=""/>
+          <p:cNvPr id="68" name=""/>
           <p:cNvSpPr/>
           <p:nvPr/>
         </p:nvSpPr>
         <p:spPr>
           <a:xfrm>
             <a:off x="900000" y="2700000"/>
-            <a:ext cx="180000" cy="345600"/>
+            <a:ext cx="179640" cy="345240"/>
           </a:xfrm>
           <a:prstGeom prst="rect">
             <a:avLst/>
@@ -7750,14 +7781,14 @@
       </p:sp>
       <p:sp>
         <p:nvSpPr>
-          <p:cNvPr id="68" name=""/>
+          <p:cNvPr id="69" name=""/>
           <p:cNvSpPr/>
           <p:nvPr/>
         </p:nvSpPr>
         <p:spPr>
           <a:xfrm>
             <a:off x="446040" y="2272680"/>
-            <a:ext cx="5385240" cy="3126600"/>
+            <a:ext cx="5384880" cy="3126240"/>
           </a:xfrm>
           <a:prstGeom prst="rect">
             <a:avLst/>
@@ -7901,14 +7932,14 @@
       </p:sp>
       <p:sp>
         <p:nvSpPr>
-          <p:cNvPr id="69" name=""/>
+          <p:cNvPr id="70" name=""/>
           <p:cNvSpPr/>
           <p:nvPr/>
         </p:nvSpPr>
         <p:spPr>
           <a:xfrm>
             <a:off x="6168240" y="2268000"/>
-            <a:ext cx="5711400" cy="2861640"/>
+            <a:ext cx="5711040" cy="2861640"/>
           </a:xfrm>
           <a:prstGeom prst="rect">
             <a:avLst/>
@@ -8037,14 +8068,14 @@
       </p:grpSpPr>
       <p:sp>
         <p:nvSpPr>
-          <p:cNvPr id="70" name="Google Shape;136;g2da54814955_3_16"/>
+          <p:cNvPr id="71" name="Google Shape;136;g2da54814955_3_16"/>
           <p:cNvSpPr/>
           <p:nvPr/>
         </p:nvSpPr>
         <p:spPr>
           <a:xfrm>
             <a:off x="1080" y="6156000"/>
-            <a:ext cx="12190320" cy="706320"/>
+            <a:ext cx="12189960" cy="705960"/>
           </a:xfrm>
           <a:prstGeom prst="rect">
             <a:avLst/>
@@ -8100,14 +8131,14 @@
       </p:sp>
       <p:sp>
         <p:nvSpPr>
-          <p:cNvPr id="71" name="Google Shape;137;g2da54814955_3_16"/>
+          <p:cNvPr id="72" name="Google Shape;137;g2da54814955_3_16"/>
           <p:cNvSpPr/>
           <p:nvPr/>
         </p:nvSpPr>
         <p:spPr>
           <a:xfrm>
             <a:off x="361080" y="59760"/>
-            <a:ext cx="7493040" cy="731880"/>
+            <a:ext cx="7492680" cy="731520"/>
           </a:xfrm>
           <a:prstGeom prst="rect">
             <a:avLst/>
@@ -8161,14 +8192,14 @@
       </p:sp>
       <p:cxnSp>
         <p:nvCxnSpPr>
-          <p:cNvPr id="72" name="Google Shape;138;g2da54814955_3_16"/>
+          <p:cNvPr id="73" name="Google Shape;138;g2da54814955_3_16"/>
           <p:cNvCxnSpPr/>
           <p:nvPr/>
         </p:nvCxnSpPr>
         <p:spPr>
           <a:xfrm>
             <a:off x="0" y="1211400"/>
-            <a:ext cx="8620200" cy="1800"/>
+            <a:ext cx="8620560" cy="2160"/>
           </a:xfrm>
           <a:prstGeom prst="straightConnector1">
             <a:avLst/>
@@ -8183,14 +8214,14 @@
       </p:cxnSp>
       <p:sp>
         <p:nvSpPr>
-          <p:cNvPr id="73" name="Google Shape;139;g2da54814955_3_16"/>
+          <p:cNvPr id="74" name="Google Shape;139;g2da54814955_3_16"/>
           <p:cNvSpPr/>
           <p:nvPr/>
         </p:nvSpPr>
         <p:spPr>
           <a:xfrm>
             <a:off x="263520" y="6223680"/>
-            <a:ext cx="11500920" cy="693360"/>
+            <a:ext cx="11500560" cy="693000"/>
           </a:xfrm>
           <a:prstGeom prst="rect">
             <a:avLst/>
@@ -8244,14 +8275,14 @@
       </p:sp>
       <p:sp>
         <p:nvSpPr>
-          <p:cNvPr id="74" name="Google Shape;140;g2da54814955_3_16"/>
+          <p:cNvPr id="75" name="Google Shape;140;g2da54814955_3_16"/>
           <p:cNvSpPr/>
           <p:nvPr/>
         </p:nvSpPr>
         <p:spPr>
           <a:xfrm>
             <a:off x="374040" y="516600"/>
-            <a:ext cx="1476720" cy="693360"/>
+            <a:ext cx="1476360" cy="693000"/>
           </a:xfrm>
           <a:prstGeom prst="rect">
             <a:avLst/>
@@ -8305,7 +8336,7 @@
       </p:sp>
       <p:pic>
         <p:nvPicPr>
-          <p:cNvPr id="75" name="Google Shape;141;g2da54814955_3_16" descr="Resultado de imagem para fatec sÃ£o roque"/>
+          <p:cNvPr id="76" name="Google Shape;141;g2da54814955_3_16" descr="Resultado de imagem para fatec sÃ£o roque"/>
           <p:cNvPicPr/>
           <p:nvPr/>
         </p:nvPicPr>
@@ -8316,7 +8347,7 @@
         <p:spPr>
           <a:xfrm>
             <a:off x="8170200" y="80280"/>
-            <a:ext cx="3828600" cy="1428120"/>
+            <a:ext cx="3828240" cy="1427760"/>
           </a:xfrm>
           <a:prstGeom prst="rect">
             <a:avLst/>
@@ -8329,14 +8360,14 @@
       </p:pic>
       <p:sp>
         <p:nvSpPr>
-          <p:cNvPr id="76" name=""/>
+          <p:cNvPr id="77" name=""/>
           <p:cNvSpPr/>
           <p:nvPr/>
         </p:nvSpPr>
         <p:spPr>
           <a:xfrm>
             <a:off x="4903200" y="3126960"/>
-            <a:ext cx="2476080" cy="472320"/>
+            <a:ext cx="2475720" cy="471960"/>
           </a:xfrm>
           <a:prstGeom prst="rect">
             <a:avLst/>
@@ -8416,14 +8447,14 @@
       </p:grpSpPr>
       <p:sp>
         <p:nvSpPr>
-          <p:cNvPr id="77" name="Google Shape;284;g2da54814955_3_58"/>
+          <p:cNvPr id="78" name="Google Shape;284;g2da54814955_3_58"/>
           <p:cNvSpPr/>
           <p:nvPr/>
         </p:nvSpPr>
         <p:spPr>
           <a:xfrm>
             <a:off x="0" y="6120000"/>
-            <a:ext cx="12191400" cy="773280"/>
+            <a:ext cx="12191040" cy="772920"/>
           </a:xfrm>
           <a:prstGeom prst="rect">
             <a:avLst/>
@@ -8479,14 +8510,14 @@
       </p:sp>
       <p:sp>
         <p:nvSpPr>
-          <p:cNvPr id="78" name="Google Shape;285;g2da54814955_3_58"/>
+          <p:cNvPr id="79" name="Google Shape;285;g2da54814955_3_58"/>
           <p:cNvSpPr/>
           <p:nvPr/>
         </p:nvSpPr>
         <p:spPr>
           <a:xfrm>
             <a:off x="361080" y="59760"/>
-            <a:ext cx="6893280" cy="731880"/>
+            <a:ext cx="6892920" cy="731520"/>
           </a:xfrm>
           <a:prstGeom prst="rect">
             <a:avLst/>
@@ -8540,14 +8571,14 @@
       </p:sp>
       <p:cxnSp>
         <p:nvCxnSpPr>
-          <p:cNvPr id="79" name="Google Shape;286;g2da54814955_3_58"/>
+          <p:cNvPr id="80" name="Google Shape;286;g2da54814955_3_58"/>
           <p:cNvCxnSpPr/>
           <p:nvPr/>
         </p:nvCxnSpPr>
         <p:spPr>
           <a:xfrm>
             <a:off x="0" y="1211400"/>
-            <a:ext cx="8620200" cy="1800"/>
+            <a:ext cx="8620560" cy="2160"/>
           </a:xfrm>
           <a:prstGeom prst="straightConnector1">
             <a:avLst/>
@@ -8562,14 +8593,14 @@
       </p:cxnSp>
       <p:sp>
         <p:nvSpPr>
-          <p:cNvPr id="80" name="Google Shape;287;g2da54814955_3_58"/>
+          <p:cNvPr id="81" name="Google Shape;287;g2da54814955_3_58"/>
           <p:cNvSpPr/>
           <p:nvPr/>
         </p:nvSpPr>
         <p:spPr>
           <a:xfrm>
             <a:off x="263520" y="6223680"/>
-            <a:ext cx="11500920" cy="693360"/>
+            <a:ext cx="11500560" cy="693000"/>
           </a:xfrm>
           <a:prstGeom prst="rect">
             <a:avLst/>
@@ -8623,14 +8654,14 @@
       </p:sp>
       <p:sp>
         <p:nvSpPr>
-          <p:cNvPr id="81" name="Google Shape;288;g2da54814955_3_58"/>
+          <p:cNvPr id="82" name="Google Shape;288;g2da54814955_3_58"/>
           <p:cNvSpPr/>
           <p:nvPr/>
         </p:nvSpPr>
         <p:spPr>
           <a:xfrm>
             <a:off x="374040" y="516600"/>
-            <a:ext cx="1476720" cy="693360"/>
+            <a:ext cx="1476360" cy="693000"/>
           </a:xfrm>
           <a:prstGeom prst="rect">
             <a:avLst/>
@@ -8684,7 +8715,7 @@
       </p:sp>
       <p:pic>
         <p:nvPicPr>
-          <p:cNvPr id="82" name="Google Shape;289;g2da54814955_3_58" descr="Resultado de imagem para fatec sÃ£o roque"/>
+          <p:cNvPr id="83" name="Google Shape;289;g2da54814955_3_58" descr="Resultado de imagem para fatec sÃ£o roque"/>
           <p:cNvPicPr/>
           <p:nvPr/>
         </p:nvPicPr>
@@ -8695,7 +8726,7 @@
         <p:spPr>
           <a:xfrm>
             <a:off x="8170200" y="80280"/>
-            <a:ext cx="3828600" cy="1428120"/>
+            <a:ext cx="3828240" cy="1427760"/>
           </a:xfrm>
           <a:prstGeom prst="rect">
             <a:avLst/>
@@ -8708,14 +8739,14 @@
       </p:pic>
       <p:sp>
         <p:nvSpPr>
-          <p:cNvPr id="83" name="Google Shape;290;g2da54814955_3_58"/>
+          <p:cNvPr id="84" name="Google Shape;290;g2da54814955_3_58"/>
           <p:cNvSpPr/>
           <p:nvPr/>
         </p:nvSpPr>
         <p:spPr>
           <a:xfrm>
             <a:off x="801360" y="1875600"/>
-            <a:ext cx="10717920" cy="4047840"/>
+            <a:ext cx="10717560" cy="4047480"/>
           </a:xfrm>
           <a:prstGeom prst="rect">
             <a:avLst/>
@@ -9218,14 +9249,14 @@
       </p:sp>
       <p:sp>
         <p:nvSpPr>
-          <p:cNvPr id="84" name="Google Shape;291;g2da54814955_3_58"/>
+          <p:cNvPr id="85" name="Google Shape;291;g2da54814955_3_58"/>
           <p:cNvSpPr/>
           <p:nvPr/>
         </p:nvSpPr>
         <p:spPr>
           <a:xfrm>
             <a:off x="374040" y="1360800"/>
-            <a:ext cx="9282240" cy="736920"/>
+            <a:ext cx="9281880" cy="736560"/>
           </a:xfrm>
           <a:prstGeom prst="rect">
             <a:avLst/>
@@ -9279,14 +9310,14 @@
       </p:sp>
       <p:sp>
         <p:nvSpPr>
-          <p:cNvPr id="85" name="Google Shape;136;g2da54814955_3_ 1"/>
+          <p:cNvPr id="86" name="Google Shape;136;g2da54814955_3_ 1"/>
           <p:cNvSpPr/>
           <p:nvPr/>
         </p:nvSpPr>
         <p:spPr>
           <a:xfrm>
             <a:off x="1080" y="6223680"/>
-            <a:ext cx="12190320" cy="638640"/>
+            <a:ext cx="12189960" cy="638280"/>
           </a:xfrm>
           <a:prstGeom prst="rect">
             <a:avLst/>
@@ -9339,14 +9370,14 @@
       </p:sp>
       <p:sp>
         <p:nvSpPr>
-          <p:cNvPr id="86" name="Google Shape;139;g2da54814955_3_ 1"/>
+          <p:cNvPr id="87" name="Google Shape;139;g2da54814955_3_ 1"/>
           <p:cNvSpPr/>
           <p:nvPr/>
         </p:nvSpPr>
         <p:spPr>
           <a:xfrm>
             <a:off x="263520" y="6223680"/>
-            <a:ext cx="11500920" cy="693360"/>
+            <a:ext cx="11500560" cy="693000"/>
           </a:xfrm>
           <a:prstGeom prst="rect">
             <a:avLst/>
@@ -9430,14 +9461,14 @@
       </p:grpSpPr>
       <p:sp>
         <p:nvSpPr>
-          <p:cNvPr id="87" name="Google Shape;284;g2da54814955_3_58"/>
+          <p:cNvPr id="88" name="Google Shape;284;g2da54814955_3_58"/>
           <p:cNvSpPr/>
           <p:nvPr/>
         </p:nvSpPr>
         <p:spPr>
           <a:xfrm>
             <a:off x="1080" y="6156000"/>
-            <a:ext cx="12190320" cy="706320"/>
+            <a:ext cx="12189960" cy="705960"/>
           </a:xfrm>
           <a:prstGeom prst="rect">
             <a:avLst/>
@@ -9493,14 +9524,14 @@
       </p:sp>
       <p:sp>
         <p:nvSpPr>
-          <p:cNvPr id="88" name="Google Shape;285;g2da54814955_3_58"/>
+          <p:cNvPr id="89" name="Google Shape;285;g2da54814955_3_58"/>
           <p:cNvSpPr/>
           <p:nvPr/>
         </p:nvSpPr>
         <p:spPr>
           <a:xfrm>
             <a:off x="361080" y="59760"/>
-            <a:ext cx="6893280" cy="731880"/>
+            <a:ext cx="6892920" cy="731520"/>
           </a:xfrm>
           <a:prstGeom prst="rect">
             <a:avLst/>
@@ -9554,14 +9585,14 @@
       </p:sp>
       <p:cxnSp>
         <p:nvCxnSpPr>
-          <p:cNvPr id="89" name="Google Shape;286;g2da54814955_3_58"/>
+          <p:cNvPr id="90" name="Google Shape;286;g2da54814955_3_58"/>
           <p:cNvCxnSpPr/>
           <p:nvPr/>
         </p:nvCxnSpPr>
         <p:spPr>
           <a:xfrm>
             <a:off x="0" y="1211400"/>
-            <a:ext cx="8620200" cy="1800"/>
+            <a:ext cx="8620560" cy="2160"/>
           </a:xfrm>
           <a:prstGeom prst="straightConnector1">
             <a:avLst/>
@@ -9576,14 +9607,14 @@
       </p:cxnSp>
       <p:sp>
         <p:nvSpPr>
-          <p:cNvPr id="90" name="Google Shape;287;g2da54814955_3_58"/>
+          <p:cNvPr id="91" name="Google Shape;287;g2da54814955_3_58"/>
           <p:cNvSpPr/>
           <p:nvPr/>
         </p:nvSpPr>
         <p:spPr>
           <a:xfrm>
             <a:off x="263520" y="6223680"/>
-            <a:ext cx="11500920" cy="693360"/>
+            <a:ext cx="11500560" cy="693000"/>
           </a:xfrm>
           <a:prstGeom prst="rect">
             <a:avLst/>
@@ -9637,14 +9668,14 @@
       </p:sp>
       <p:sp>
         <p:nvSpPr>
-          <p:cNvPr id="91" name="Google Shape;288;g2da54814955_3_58"/>
+          <p:cNvPr id="92" name="Google Shape;288;g2da54814955_3_58"/>
           <p:cNvSpPr/>
           <p:nvPr/>
         </p:nvSpPr>
         <p:spPr>
           <a:xfrm>
             <a:off x="374040" y="516600"/>
-            <a:ext cx="1476720" cy="693360"/>
+            <a:ext cx="1476360" cy="693000"/>
           </a:xfrm>
           <a:prstGeom prst="rect">
             <a:avLst/>
@@ -9698,7 +9729,7 @@
       </p:sp>
       <p:pic>
         <p:nvPicPr>
-          <p:cNvPr id="92" name="Google Shape;289;g2da54814955_3_58" descr="Resultado de imagem para fatec sÃ£o roque"/>
+          <p:cNvPr id="93" name="Google Shape;289;g2da54814955_3_58" descr="Resultado de imagem para fatec sÃ£o roque"/>
           <p:cNvPicPr/>
           <p:nvPr/>
         </p:nvPicPr>
@@ -9709,7 +9740,7 @@
         <p:spPr>
           <a:xfrm>
             <a:off x="8170200" y="80280"/>
-            <a:ext cx="3828600" cy="1428120"/>
+            <a:ext cx="3828240" cy="1427760"/>
           </a:xfrm>
           <a:prstGeom prst="rect">
             <a:avLst/>
@@ -9722,14 +9753,14 @@
       </p:pic>
       <p:sp>
         <p:nvSpPr>
-          <p:cNvPr id="93" name="Google Shape;290;g2da54814955_3_58"/>
+          <p:cNvPr id="94" name="Google Shape;290;g2da54814955_3_58"/>
           <p:cNvSpPr/>
           <p:nvPr/>
         </p:nvSpPr>
         <p:spPr>
           <a:xfrm>
             <a:off x="801360" y="1875600"/>
-            <a:ext cx="10537920" cy="4047840"/>
+            <a:ext cx="10537560" cy="4047480"/>
           </a:xfrm>
           <a:prstGeom prst="rect">
             <a:avLst/>
@@ -9867,14 +9898,14 @@
       </p:sp>
       <p:sp>
         <p:nvSpPr>
-          <p:cNvPr id="94" name="Google Shape;291;g2da54814955_3_58"/>
+          <p:cNvPr id="95" name="Google Shape;291;g2da54814955_3_58"/>
           <p:cNvSpPr/>
           <p:nvPr/>
         </p:nvSpPr>
         <p:spPr>
           <a:xfrm>
             <a:off x="374040" y="1360800"/>
-            <a:ext cx="9282240" cy="736920"/>
+            <a:ext cx="9281880" cy="736560"/>
           </a:xfrm>
           <a:prstGeom prst="rect">
             <a:avLst/>
@@ -9958,14 +9989,14 @@
       </p:grpSpPr>
       <p:sp>
         <p:nvSpPr>
-          <p:cNvPr id="95" name="Google Shape;284;g2da54814955_3_ 1"/>
+          <p:cNvPr id="96" name="Google Shape;284;g2da54814955_3_ 1"/>
           <p:cNvSpPr/>
           <p:nvPr/>
         </p:nvSpPr>
         <p:spPr>
           <a:xfrm>
             <a:off x="1080" y="6168960"/>
-            <a:ext cx="12190320" cy="706320"/>
+            <a:ext cx="12189960" cy="705960"/>
           </a:xfrm>
           <a:prstGeom prst="rect">
             <a:avLst/>
@@ -10018,14 +10049,14 @@
       </p:sp>
       <p:sp>
         <p:nvSpPr>
-          <p:cNvPr id="96" name="Google Shape;285;g2da54814955_3_ 2"/>
+          <p:cNvPr id="97" name="Google Shape;285;g2da54814955_3_ 2"/>
           <p:cNvSpPr/>
           <p:nvPr/>
         </p:nvSpPr>
         <p:spPr>
           <a:xfrm>
             <a:off x="361080" y="59760"/>
-            <a:ext cx="6893280" cy="731880"/>
+            <a:ext cx="6892920" cy="731520"/>
           </a:xfrm>
           <a:prstGeom prst="rect">
             <a:avLst/>
@@ -10079,14 +10110,14 @@
       </p:sp>
       <p:cxnSp>
         <p:nvCxnSpPr>
-          <p:cNvPr id="97" name="Google Shape;286;g2da54814955_3_ 2"/>
+          <p:cNvPr id="98" name="Google Shape;286;g2da54814955_3_ 2"/>
           <p:cNvCxnSpPr/>
           <p:nvPr/>
         </p:nvCxnSpPr>
         <p:spPr>
           <a:xfrm>
             <a:off x="0" y="1211400"/>
-            <a:ext cx="8620200" cy="1800"/>
+            <a:ext cx="8620560" cy="2160"/>
           </a:xfrm>
           <a:prstGeom prst="straightConnector1">
             <a:avLst/>
@@ -10101,14 +10132,14 @@
       </p:cxnSp>
       <p:sp>
         <p:nvSpPr>
-          <p:cNvPr id="98" name="Google Shape;287;g2da54814955_3_ 2"/>
+          <p:cNvPr id="99" name="Google Shape;287;g2da54814955_3_ 2"/>
           <p:cNvSpPr/>
           <p:nvPr/>
         </p:nvSpPr>
         <p:spPr>
           <a:xfrm>
             <a:off x="263520" y="6223680"/>
-            <a:ext cx="11500920" cy="693360"/>
+            <a:ext cx="11500560" cy="693000"/>
           </a:xfrm>
           <a:prstGeom prst="rect">
             <a:avLst/>
@@ -10162,14 +10193,14 @@
       </p:sp>
       <p:sp>
         <p:nvSpPr>
-          <p:cNvPr id="99" name="Google Shape;288;g2da54814955_3_ 2"/>
+          <p:cNvPr id="100" name="Google Shape;288;g2da54814955_3_ 2"/>
           <p:cNvSpPr/>
           <p:nvPr/>
         </p:nvSpPr>
         <p:spPr>
           <a:xfrm>
             <a:off x="374040" y="516600"/>
-            <a:ext cx="1476720" cy="693360"/>
+            <a:ext cx="1476360" cy="693000"/>
           </a:xfrm>
           <a:prstGeom prst="rect">
             <a:avLst/>
@@ -10223,7 +10254,7 @@
       </p:sp>
       <p:pic>
         <p:nvPicPr>
-          <p:cNvPr id="100" name="Google Shape;289;g2da54814955_3_ 2" descr="Resultado de imagem para fatec sÃ£o roque"/>
+          <p:cNvPr id="101" name="Google Shape;289;g2da54814955_3_ 2" descr="Resultado de imagem para fatec sÃ£o roque"/>
           <p:cNvPicPr/>
           <p:nvPr/>
         </p:nvPicPr>
@@ -10234,7 +10265,7 @@
         <p:spPr>
           <a:xfrm>
             <a:off x="8170200" y="80280"/>
-            <a:ext cx="3828600" cy="1428120"/>
+            <a:ext cx="3828240" cy="1427760"/>
           </a:xfrm>
           <a:prstGeom prst="rect">
             <a:avLst/>
@@ -10247,14 +10278,14 @@
       </p:pic>
       <p:sp>
         <p:nvSpPr>
-          <p:cNvPr id="101" name="Google Shape;290;g2da54814955_3_ 2"/>
+          <p:cNvPr id="102" name="Google Shape;290;g2da54814955_3_ 2"/>
           <p:cNvSpPr/>
           <p:nvPr/>
         </p:nvSpPr>
         <p:spPr>
           <a:xfrm>
             <a:off x="801360" y="1712160"/>
-            <a:ext cx="11257920" cy="4047840"/>
+            <a:ext cx="11257560" cy="4047480"/>
           </a:xfrm>
           <a:prstGeom prst="rect">
             <a:avLst/>
@@ -10605,14 +10636,14 @@
       </p:sp>
       <p:sp>
         <p:nvSpPr>
-          <p:cNvPr id="102" name="Google Shape;291;g2da54814955_3_ 2"/>
+          <p:cNvPr id="103" name="Google Shape;291;g2da54814955_3_ 2"/>
           <p:cNvSpPr/>
           <p:nvPr/>
         </p:nvSpPr>
         <p:spPr>
           <a:xfrm>
             <a:off x="374040" y="1360800"/>
-            <a:ext cx="9282240" cy="731160"/>
+            <a:ext cx="9281880" cy="731160"/>
           </a:xfrm>
           <a:prstGeom prst="rect">
             <a:avLst/>

</xml_diff>